<commit_message>
feat: turn FoodShock into a multi-incident framework demo
</commit_message>
<xml_diff>
--- a/deliverables/FoodShock_pitch_deck.pptx
+++ b/deliverables/FoodShock_pitch_deck.pptx
@@ -1281,7 +1281,7 @@
           <a:p>
             <a:r>
               <a:rPr lang="en-US" dirty="0"/>
-              <a:t>The recommended plan adds 1,800 pounds served, cuts unmet demand by the same amount, raises the worst pantry fill rate by 21.8 percentage points, and eliminates 180 disrupted boxes for 990 dollars. The runtime is a measured software run; the manual-time comparator remains hypothetical and is intentionally excluded from the chart.</a:t>
+              <a:t>The recommended plan adds 1,800 pounds served, cuts unmet demand by the same amount, raises the worst pantry fill rate by 21.8 percentage points, and cuts disrupted boxes from 248 to 68 for 990 dollars. The runtime is a measured software run; the manual-time comparator remains hypothetical and is intentionally excluded from the chart.</a:t>
             </a:r>
             <a:endParaRPr lang="en-US" dirty="0"/>
           </a:p>
@@ -3213,7 +3213,7 @@
                 <a:ea typeface="Aptos Display" pitchFamily="34" charset="-122"/>
                 <a:cs typeface="Aptos Display" pitchFamily="34" charset="-120"/>
               </a:rPr>
-              <a:t>0.81s</a:t>
+              <a:t>1.20s</a:t>
             </a:r>
             <a:endParaRPr lang="en-US" sz="2500" dirty="0"/>
           </a:p>
@@ -10905,7 +10905,7 @@
                 <a:ea typeface="Aptos Display" pitchFamily="34" charset="-122"/>
                 <a:cs typeface="Aptos Display" pitchFamily="34" charset="-120"/>
               </a:rPr>
-              <a:t>0</a:t>
+              <a:t>68</a:t>
             </a:r>
             <a:endParaRPr lang="en-US" sz="2500" dirty="0"/>
           </a:p>
@@ -10987,7 +10987,7 @@
                 <a:ea typeface="Aptos" pitchFamily="34" charset="-122"/>
                 <a:cs typeface="Aptos" pitchFamily="34" charset="-120"/>
               </a:rPr>
-              <a:t>from 180</a:t>
+              <a:t>from 248</a:t>
             </a:r>
             <a:endParaRPr lang="en-US" sz="850" dirty="0"/>
           </a:p>
@@ -11605,7 +11605,7 @@
                 <a:ea typeface="Aptos Display" pitchFamily="34" charset="-122"/>
                 <a:cs typeface="Aptos Display" pitchFamily="34" charset="-120"/>
               </a:rPr>
-              <a:t>0.81s</a:t>
+              <a:t>1.20s</a:t>
             </a:r>
             <a:endParaRPr lang="en-US" sz="2500" dirty="0"/>
           </a:p>
@@ -13174,7 +13174,7 @@
                 <a:ea typeface="Aptos" pitchFamily="34" charset="-122"/>
                 <a:cs typeface="Aptos" pitchFamily="34" charset="-120"/>
               </a:rPr>
-              <a:t>0.81s</a:t>
+              <a:t>1.20s</a:t>
             </a:r>
             <a:endParaRPr lang="en-US" sz="1250" dirty="0"/>
           </a:p>
@@ -13420,7 +13420,7 @@
                 <a:ea typeface="Aptos" pitchFamily="34" charset="-122"/>
                 <a:cs typeface="Aptos" pitchFamily="34" charset="-120"/>
               </a:rPr>
-              <a:t>8 tests</a:t>
+              <a:t>64 tests</a:t>
             </a:r>
             <a:endParaRPr lang="en-US" sz="1250" dirty="0"/>
           </a:p>
@@ -13461,7 +13461,7 @@
                 <a:ea typeface="Aptos" pitchFamily="34" charset="-122"/>
                 <a:cs typeface="Aptos" pitchFamily="34" charset="-120"/>
               </a:rPr>
-              <a:t>new safety regressions</a:t>
+              <a:t>deterministic regression suite</a:t>
             </a:r>
             <a:endParaRPr lang="en-US" sz="960" dirty="0"/>
           </a:p>

</xml_diff>

<commit_message>
feat: ingest live FDA and USDA incidents
</commit_message>
<xml_diff>
--- a/deliverables/FoodShock_pitch_deck.pptx
+++ b/deliverables/FoodShock_pitch_deck.pptx
@@ -841,7 +841,7 @@
           <a:p>
             <a:r>
               <a:rPr lang="en-US" dirty="0"/>
-              <a:t>FoodShock is a decision-support command center for food-bank recall response. The core promise is not autonomous execution: it is faster, traceable analysis ending at a human approval gate. All operational data in this demonstration is synthetic.</a:t>
+              <a:t>FoodShock is a decision-support command center for food-bank recall response. Current openFDA and USDA FSIS incidents enter through official APIs, while inventory, purchase orders, demand, and recovery offers remain synthetic. The system ends at a human approval gate and exposes no action when an authority incident has no linked lot or purchase order.</a:t>
             </a:r>
             <a:endParaRPr lang="en-US" dirty="0"/>
           </a:p>
@@ -1105,7 +1105,7 @@
           <a:p>
             <a:r>
               <a:rPr lang="en-US" dirty="0"/>
-              <a:t>The architectural boundary is deliberate: language-model output cannot directly mutate inventory or approve a plan. Approval revalidates plan identity, payload integrity, and hard constraints inside the state layer.</a:t>
+              <a:t>The architectural boundary is deliberate. Each authority feed fails independently. Structured API fields are verified against the retained normalized source snapshot, and malformed fields cannot become operational facts. Language-model output cannot mutate inventory or approve a plan; approval revalidates identity, payload integrity, and hard constraints inside the state layer.</a:t>
             </a:r>
             <a:endParaRPr lang="en-US" dirty="0"/>
           </a:p>
@@ -1193,7 +1193,7 @@
           <a:p>
             <a:r>
               <a:rPr lang="en-US" dirty="0"/>
-              <a:t>The screenshot is not a mockup. It is the public Streamlit deployment. Verbatim excerpts remain alongside structured fields so a reviewer can challenge extraction before acting.</a:t>
+              <a:t>The screenshot is not a mockup; it is the public Streamlit application running the deterministic positive-exposure fallback. Current openFDA and USDA FSIS records retain the same field-level provenance, authority warning, retrieval time, and source link. If no synthetic lot or purchase order joins to that real incident, FoodShock presents an explicit no-exposure result instead of manufacturing a recovery action.</a:t>
             </a:r>
             <a:endParaRPr lang="en-US" dirty="0"/>
           </a:p>
@@ -1457,7 +1457,7 @@
           <a:p>
             <a:r>
               <a:rPr lang="en-US" dirty="0"/>
-              <a:t>The deck does not report extraction accuracy because a valid Anthropic credential was unavailable. The gold set and scorer are committed so the run can be reproduced once access exists. The operational results are also explicitly synthetic and not operator-validated.</a:t>
+              <a:t>The live source adapters retrieve current openFDA and USDA FSIS records, but an authority record is not evidence that the synthetic network is exposed. The deck does not report extraction accuracy because a valid Anthropic credential was unavailable. The gold set and scorer are committed for a reproducible future run. Operational outcomes remain synthetic and are not operator-validated.</a:t>
             </a:r>
             <a:endParaRPr lang="en-US" dirty="0"/>
           </a:p>
@@ -1545,7 +1545,7 @@
           <a:p>
             <a:r>
               <a:rPr lang="en-US" dirty="0"/>
-              <a:t>The proposed next step is a bounded shadow pilot. The goal is to validate the workflow and evidence loop with operators before making impact claims. The public demo and source code are available from this slide.</a:t>
+              <a:t>The proposed next step is a bounded shadow pilot. The public command center already accepts current openFDA and USDA FSIS incidents while keeping food-bank operations synthetic. The goal of a pilot is to connect real operational records and validate the evidence loop with operators before making impact claims.</a:t>
             </a:r>
             <a:endParaRPr lang="en-US" dirty="0"/>
           </a:p>
@@ -2595,7 +2595,7 @@
                 <a:ea typeface="Aptos" pitchFamily="34" charset="-122"/>
                 <a:cs typeface="Aptos" pitchFamily="34" charset="-120"/>
               </a:rPr>
-              <a:t>extract</a:t>
+              <a:t>live authority</a:t>
             </a:r>
             <a:endParaRPr lang="en-US" sz="850" dirty="0"/>
           </a:p>
@@ -3776,7 +3776,7 @@
         <p:spPr>
           <a:xfrm>
             <a:off x="658368" y="6327648"/>
-            <a:ext cx="6309360" cy="228600"/>
+            <a:ext cx="6766560" cy="228600"/>
           </a:xfrm>
           <a:prstGeom prst="rect">
             <a:avLst/>
@@ -3802,7 +3802,7 @@
                 <a:ea typeface="Aptos" pitchFamily="34" charset="-122"/>
                 <a:cs typeface="Aptos" pitchFamily="34" charset="-120"/>
               </a:rPr>
-              <a:t>Synthetic operations data. No client PII. No operator validation claimed.</a:t>
+              <a:t>Live FDA/USDA incidents. Synthetic food-bank operations. No client PII.</a:t>
             </a:r>
             <a:endParaRPr lang="en-US" sz="900" dirty="0"/>
           </a:p>
@@ -7127,7 +7127,7 @@
         <p:spPr>
           <a:xfrm>
             <a:off x="658368" y="1572768"/>
-            <a:ext cx="10698480" cy="530352"/>
+            <a:ext cx="10698480" cy="603504"/>
           </a:xfrm>
           <a:prstGeom prst="rect">
             <a:avLst/>
@@ -7145,7 +7145,7 @@
               <a:buNone/>
             </a:pPr>
             <a:r>
-              <a:rPr lang="en-US" sz="1600" dirty="0">
+              <a:rPr lang="en-US" sz="1500" dirty="0">
                 <a:solidFill>
                   <a:srgbClr val="61706D"/>
                 </a:solidFill>
@@ -7153,9 +7153,9 @@
                 <a:ea typeface="Aptos" pitchFamily="34" charset="-122"/>
                 <a:cs typeface="Aptos" pitchFamily="34" charset="-120"/>
               </a:rPr>
-              <a:t>The agent gathers and explains evidence. Typed tools, state projection, optimization, and approval checks decide what is feasible and what may execute.</a:t>
-            </a:r>
-            <a:endParaRPr lang="en-US" sz="1600" dirty="0"/>
+              <a:t>Current openFDA and FSIS incidents cross a provenance-verified source boundary before the agent joins them to synthetic operations. Zero linked lots or POs means zero exposure and no approval action.</a:t>
+            </a:r>
+            <a:endParaRPr lang="en-US" sz="1500" dirty="0"/>
           </a:p>
         </p:txBody>
       </p:sp>
@@ -7303,7 +7303,7 @@
                 <a:ea typeface="Aptos" pitchFamily="34" charset="-122"/>
                 <a:cs typeface="Aptos" pitchFamily="34" charset="-120"/>
               </a:rPr>
-              <a:t>notice + state</a:t>
+              <a:t>official feed + state</a:t>
             </a:r>
             <a:endParaRPr lang="en-US" sz="880" dirty="0"/>
           </a:p>
@@ -8751,7 +8751,7 @@
                 <a:ea typeface="Aptos" pitchFamily="34" charset="-122"/>
                 <a:cs typeface="Aptos" pitchFamily="34" charset="-120"/>
               </a:rPr>
-              <a:t>SQLite</a:t>
+              <a:t>openFDA + FSIS</a:t>
             </a:r>
             <a:endParaRPr lang="en-US" sz="1150" dirty="0"/>
           </a:p>
@@ -8792,7 +8792,7 @@
                 <a:ea typeface="Aptos" pitchFamily="34" charset="-122"/>
                 <a:cs typeface="Aptos" pitchFamily="34" charset="-120"/>
               </a:rPr>
-              <a:t>auditable incident state</a:t>
+              <a:t>live authority incidents</a:t>
             </a:r>
             <a:endParaRPr lang="en-US" sz="950" dirty="0"/>
           </a:p>
@@ -8899,7 +8899,7 @@
                 <a:ea typeface="Aptos" pitchFamily="34" charset="-122"/>
                 <a:cs typeface="Aptos" pitchFamily="34" charset="-120"/>
               </a:rPr>
-              <a:t>NetworkX</a:t>
+              <a:t>SQLite + NetworkX</a:t>
             </a:r>
             <a:endParaRPr lang="en-US" sz="1150" dirty="0"/>
           </a:p>
@@ -8940,7 +8940,7 @@
                 <a:ea typeface="Aptos" pitchFamily="34" charset="-122"/>
                 <a:cs typeface="Aptos" pitchFamily="34" charset="-120"/>
               </a:rPr>
-              <a:t>recall-to-pantry lineage</a:t>
+              <a:t>auditable state + lineage</a:t>
             </a:r>
             <a:endParaRPr lang="en-US" sz="950" dirty="0"/>
           </a:p>
@@ -9277,7 +9277,7 @@
                 <a:ea typeface="Aptos" pitchFamily="34" charset="-122"/>
                 <a:cs typeface="Aptos" pitchFamily="34" charset="-120"/>
               </a:rPr>
-              <a:t>LLM narration can be cached/template-only; execution safety does not depend on free-form text.  </a:t>
+              <a:t>Authority incidents are real; operational records and computed impacts remain synthetic.  </a:t>
             </a:r>
             <a:pPr indent="0" marL="0">
               <a:buNone/>
@@ -9295,7 +9295,7 @@
                 <a:latin typeface="Aptos" pitchFamily="34" charset="0"/>
                 <a:ea typeface="Aptos" pitchFamily="34" charset="-122"/>
                 <a:cs typeface="Aptos" pitchFamily="34" charset="-120"/>
-                <a:hlinkClick r:id="rId1" invalidUrl="" action="" tgtFrame="" tooltip="Architecture and source" history="1" highlightClick="0" endSnd="0">
+                <a:hlinkClick r:id="rId1" invalidUrl="" action="" tgtFrame="" tooltip="Technical architecture" history="1" highlightClick="0" endSnd="0">
                   <a:extLst>
                     <a:ext uri="{A12FA001-AC4F-418D-AE19-62706E023703}">
                       <ahyp:hlinkClr xmlns:ahyp="http://schemas.microsoft.com/office/drawing/2018/hyperlinkcolor" val="tx"/>
@@ -9303,7 +9303,7 @@
                   </a:extLst>
                 </a:hlinkClick>
               </a:rPr>
-              <a:t>Architecture and source</a:t>
+              <a:t>Technical architecture</a:t>
             </a:r>
             <a:pPr indent="0" marL="0">
               <a:buNone/>
@@ -9335,7 +9335,47 @@
                 <a:latin typeface="Aptos" pitchFamily="34" charset="0"/>
                 <a:ea typeface="Aptos" pitchFamily="34" charset="-122"/>
                 <a:cs typeface="Aptos" pitchFamily="34" charset="-120"/>
-                <a:hlinkClick r:id="rId2" invalidUrl="" action="" tgtFrame="" tooltip="Approval implementation" history="1" highlightClick="0" endSnd="0">
+                <a:hlinkClick r:id="rId2" invalidUrl="" action="" tgtFrame="" tooltip="Official source adapters" history="1" highlightClick="0" endSnd="0">
+                  <a:extLst>
+                    <a:ext uri="{A12FA001-AC4F-418D-AE19-62706E023703}">
+                      <ahyp:hlinkClr xmlns:ahyp="http://schemas.microsoft.com/office/drawing/2018/hyperlinkcolor" val="tx"/>
+                    </a:ext>
+                  </a:extLst>
+                </a:hlinkClick>
+              </a:rPr>
+              <a:t>Official source adapters</a:t>
+            </a:r>
+            <a:pPr indent="0" marL="0">
+              <a:buNone/>
+            </a:pPr>
+            <a:r>
+              <a:rPr lang="en-US" sz="850" dirty="0">
+                <a:solidFill>
+                  <a:srgbClr val="D9D2C2"/>
+                </a:solidFill>
+                <a:latin typeface="Aptos" pitchFamily="34" charset="0"/>
+                <a:ea typeface="Aptos" pitchFamily="34" charset="-122"/>
+                <a:cs typeface="Aptos" pitchFamily="34" charset="-120"/>
+              </a:rPr>
+              <a:t>  |  </a:t>
+            </a:r>
+            <a:pPr indent="0" marL="0">
+              <a:buNone/>
+            </a:pPr>
+            <a:r>
+              <a:rPr lang="en-US" sz="850" u="sng" dirty="0">
+                <a:solidFill>
+                  <a:srgbClr val="1D6B62"/>
+                </a:solidFill>
+                <a:uFill>
+                  <a:solidFill>
+                    <a:srgbClr val="1D6B62"/>
+                  </a:solidFill>
+                </a:uFill>
+                <a:latin typeface="Aptos" pitchFamily="34" charset="0"/>
+                <a:ea typeface="Aptos" pitchFamily="34" charset="-122"/>
+                <a:cs typeface="Aptos" pitchFamily="34" charset="-120"/>
+                <a:hlinkClick r:id="rId3" invalidUrl="" action="" tgtFrame="" tooltip="Approval implementation" history="1" highlightClick="0" endSnd="0">
                   <a:extLst>
                     <a:ext uri="{A12FA001-AC4F-418D-AE19-62706E023703}">
                       <ahyp:hlinkClr xmlns:ahyp="http://schemas.microsoft.com/office/drawing/2018/hyperlinkcolor" val="tx"/>
@@ -9531,7 +9571,7 @@
               <a:buNone/>
             </a:pPr>
             <a:r>
-              <a:rPr lang="en-US" sz="1550" dirty="0">
+              <a:rPr lang="en-US" sz="1520" dirty="0">
                 <a:solidFill>
                   <a:srgbClr val="61706D"/>
                 </a:solidFill>
@@ -9539,9 +9579,9 @@
                 <a:ea typeface="Aptos" pitchFamily="34" charset="-122"/>
                 <a:cs typeface="Aptos" pitchFamily="34" charset="-120"/>
               </a:rPr>
-              <a:t>The exposure view pairs typed incident facts with verbatim source excerpts, then follows exact lot and purchase-order lineage into the operating network.</a:t>
-            </a:r>
-            <a:endParaRPr lang="en-US" sz="1550" dirty="0"/>
+              <a:t>The curated positive-exposure view pairs typed incident facts with verbatim source excerpts and exact operational lineage. Live API incidents use the same evidence contract and can stop honestly at zero exposure.</a:t>
+            </a:r>
+            <a:endParaRPr lang="en-US" sz="1520" dirty="0"/>
           </a:p>
         </p:txBody>
       </p:sp>
@@ -9765,7 +9805,7 @@
                 <a:ea typeface="Aptos" pitchFamily="34" charset="-122"/>
                 <a:cs typeface="Aptos" pitchFamily="34" charset="-120"/>
               </a:rPr>
-              <a:t>Original notice retained</a:t>
+              <a:t>Source snapshot retained</a:t>
             </a:r>
             <a:endParaRPr lang="en-US" sz="1150" dirty="0"/>
           </a:p>
@@ -9806,7 +9846,7 @@
                 <a:ea typeface="Aptos" pitchFamily="34" charset="-122"/>
                 <a:cs typeface="Aptos" pitchFamily="34" charset="-120"/>
               </a:rPr>
-              <a:t>raw text remains inspectable</a:t>
+              <a:t>input remains inspectable</a:t>
             </a:r>
             <a:endParaRPr lang="en-US" sz="950" dirty="0"/>
           </a:p>
@@ -10291,7 +10331,7 @@
                 <a:ea typeface="Aptos" pitchFamily="34" charset="-122"/>
                 <a:cs typeface="Aptos" pitchFamily="34" charset="-120"/>
               </a:rPr>
-              <a:t>Screenshot captured from the public synthetic-data demo.  </a:t>
+              <a:t>Screenshot: curated positive-exposure fallback. Live authority incidents use the same provenance contract.  </a:t>
             </a:r>
             <a:pPr indent="0" marL="0">
               <a:buNone/>
@@ -13133,7 +13173,7 @@
                 <a:ea typeface="Aptos" pitchFamily="34" charset="-122"/>
                 <a:cs typeface="Aptos" pitchFamily="34" charset="-120"/>
               </a:rPr>
-              <a:t>In the synthetic demo</a:t>
+              <a:t>Implemented + measured</a:t>
             </a:r>
             <a:endParaRPr lang="en-US" sz="1450" dirty="0"/>
           </a:p>
@@ -13174,7 +13214,7 @@
                 <a:ea typeface="Aptos" pitchFamily="34" charset="-122"/>
                 <a:cs typeface="Aptos" pitchFamily="34" charset="-120"/>
               </a:rPr>
-              <a:t>1.20s</a:t>
+              <a:t>2 feeds</a:t>
             </a:r>
             <a:endParaRPr lang="en-US" sz="1250" dirty="0"/>
           </a:p>
@@ -13215,7 +13255,7 @@
                 <a:ea typeface="Aptos" pitchFamily="34" charset="-122"/>
                 <a:cs typeface="Aptos" pitchFamily="34" charset="-120"/>
               </a:rPr>
-              <a:t>latest seeded run</a:t>
+              <a:t>on-demand openFDA + FSIS</a:t>
             </a:r>
             <a:endParaRPr lang="en-US" sz="960" dirty="0"/>
           </a:p>
@@ -13256,7 +13296,7 @@
                 <a:ea typeface="Aptos" pitchFamily="34" charset="-122"/>
                 <a:cs typeface="Aptos" pitchFamily="34" charset="-120"/>
               </a:rPr>
-              <a:t>0</a:t>
+              <a:t>78 tests</a:t>
             </a:r>
             <a:endParaRPr lang="en-US" sz="1250" dirty="0"/>
           </a:p>
@@ -13297,7 +13337,7 @@
                 <a:ea typeface="Aptos" pitchFamily="34" charset="-122"/>
                 <a:cs typeface="Aptos" pitchFamily="34" charset="-120"/>
               </a:rPr>
-              <a:t>hard-constraint violations</a:t>
+              <a:t>deterministic regression suite</a:t>
             </a:r>
             <a:endParaRPr lang="en-US" sz="960" dirty="0"/>
           </a:p>
@@ -13338,7 +13378,7 @@
                 <a:ea typeface="Aptos" pitchFamily="34" charset="-122"/>
                 <a:cs typeface="Aptos" pitchFamily="34" charset="-120"/>
               </a:rPr>
-              <a:t>+1,800 lb</a:t>
+              <a:t>0</a:t>
             </a:r>
             <a:endParaRPr lang="en-US" sz="1250" dirty="0"/>
           </a:p>
@@ -13379,7 +13419,7 @@
                 <a:ea typeface="Aptos" pitchFamily="34" charset="-122"/>
                 <a:cs typeface="Aptos" pitchFamily="34" charset="-120"/>
               </a:rPr>
-              <a:t>served vs baseline</a:t>
+              <a:t>hard-constraint violations</a:t>
             </a:r>
             <a:endParaRPr lang="en-US" sz="960" dirty="0"/>
           </a:p>
@@ -13420,7 +13460,7 @@
                 <a:ea typeface="Aptos" pitchFamily="34" charset="-122"/>
                 <a:cs typeface="Aptos" pitchFamily="34" charset="-120"/>
               </a:rPr>
-              <a:t>64 tests</a:t>
+              <a:t>+1,800 lb</a:t>
             </a:r>
             <a:endParaRPr lang="en-US" sz="1250" dirty="0"/>
           </a:p>
@@ -13461,7 +13501,7 @@
                 <a:ea typeface="Aptos" pitchFamily="34" charset="-122"/>
                 <a:cs typeface="Aptos" pitchFamily="34" charset="-120"/>
               </a:rPr>
-              <a:t>deterministic regression suite</a:t>
+              <a:t>curated recovery vs baseline</a:t>
             </a:r>
             <a:endParaRPr lang="en-US" sz="960" dirty="0"/>
           </a:p>
@@ -15629,17 +15669,17 @@
         <p:spPr>
           <a:xfrm>
             <a:off x="7726680" y="5532120"/>
-            <a:ext cx="1325880" cy="274320"/>
+            <a:ext cx="2286000" cy="274320"/>
           </a:xfrm>
           <a:prstGeom prst="roundRect">
             <a:avLst/>
           </a:prstGeom>
           <a:solidFill>
-            <a:srgbClr val="B94735"/>
+            <a:srgbClr val="1D6B62"/>
           </a:solidFill>
           <a:ln w="12700">
             <a:solidFill>
-              <a:srgbClr val="B94735"/>
+              <a:srgbClr val="1D6B62"/>
             </a:solidFill>
             <a:prstDash val="solid"/>
           </a:ln>
@@ -15654,7 +15694,7 @@
         <p:spPr>
           <a:xfrm>
             <a:off x="7799832" y="5559552"/>
-            <a:ext cx="1179576" cy="210312"/>
+            <a:ext cx="2139696" cy="210312"/>
           </a:xfrm>
           <a:prstGeom prst="rect">
             <a:avLst/>
@@ -15680,7 +15720,7 @@
                 <a:ea typeface="Aptos" pitchFamily="34" charset="-122"/>
                 <a:cs typeface="Aptos" pitchFamily="34" charset="-120"/>
               </a:rPr>
-              <a:t>SYNTHETIC DATA</a:t>
+              <a:t>LIVE FEEDS · SYNTHETIC OPS</a:t>
             </a:r>
             <a:endParaRPr lang="en-US" sz="900" dirty="0"/>
           </a:p>
@@ -15694,26 +15734,26 @@
         </p:nvSpPr>
         <p:spPr>
           <a:xfrm>
-            <a:off x="9217152" y="5522976"/>
-            <a:ext cx="1874520" cy="283464"/>
-          </a:xfrm>
-          <a:prstGeom prst="rect">
-            <a:avLst/>
-          </a:prstGeom>
-          <a:noFill/>
-          <a:ln/>
-        </p:spPr>
-        <p:txBody>
-          <a:bodyPr wrap="square" lIns="0" tIns="0" rIns="0" bIns="0" rtlCol="0" anchor="ctr">
-            <a:normAutofit/>
-          </a:bodyPr>
-          <a:lstStyle/>
-          <a:p>
-            <a:pPr indent="0" marL="0">
-              <a:buNone/>
-            </a:pPr>
-            <a:r>
-              <a:rPr lang="en-US" sz="950" dirty="0">
+            <a:off x="10168128" y="5522976"/>
+            <a:ext cx="1024128" cy="283464"/>
+          </a:xfrm>
+          <a:prstGeom prst="rect">
+            <a:avLst/>
+          </a:prstGeom>
+          <a:noFill/>
+          <a:ln/>
+        </p:spPr>
+        <p:txBody>
+          <a:bodyPr wrap="square" lIns="0" tIns="0" rIns="0" bIns="0" rtlCol="0" anchor="ctr">
+            <a:normAutofit/>
+          </a:bodyPr>
+          <a:lstStyle/>
+          <a:p>
+            <a:pPr indent="0" marL="0">
+              <a:buNone/>
+            </a:pPr>
+            <a:r>
+              <a:rPr lang="en-US" sz="920" dirty="0">
                 <a:solidFill>
                   <a:srgbClr val="61706D"/>
                 </a:solidFill>
@@ -15721,9 +15761,9 @@
                 <a:ea typeface="Aptos" pitchFamily="34" charset="-122"/>
                 <a:cs typeface="Aptos" pitchFamily="34" charset="-120"/>
               </a:rPr>
-              <a:t>No client PII. Human approval required.</a:t>
-            </a:r>
-            <a:endParaRPr lang="en-US" sz="950" dirty="0"/>
+              <a:t>Human gate required.</a:t>
+            </a:r>
+            <a:endParaRPr lang="en-US" sz="920" dirty="0"/>
           </a:p>
         </p:txBody>
       </p:sp>

</xml_diff>